<commit_message>
documentation: added more docs to WingConfiguration
</commit_message>
<xml_diff>
--- a/docs/images/images with text.pptx
+++ b/docs/images/images with text.pptx
@@ -9,6 +9,10 @@
     <p:sldId id="257" r:id="rId3"/>
     <p:sldId id="258" r:id="rId4"/>
     <p:sldId id="259" r:id="rId5"/>
+    <p:sldId id="260" r:id="rId6"/>
+    <p:sldId id="261" r:id="rId7"/>
+    <p:sldId id="262" r:id="rId8"/>
+    <p:sldId id="263" r:id="rId9"/>
   </p:sldIdLst>
   <p:sldSz cx="12192000" cy="6858000"/>
   <p:notesSz cx="6858000" cy="9144000"/>
@@ -262,7 +266,7 @@
           <a:p>
             <a:fld id="{44DFB032-A503-954A-98BF-23F6F2D4C668}" type="datetimeFigureOut">
               <a:rPr lang="de-DE" smtClean="0"/>
-              <a:t>11.04.24</a:t>
+              <a:t>15.04.24</a:t>
             </a:fld>
             <a:endParaRPr lang="de-DE"/>
           </a:p>
@@ -460,7 +464,7 @@
           <a:p>
             <a:fld id="{44DFB032-A503-954A-98BF-23F6F2D4C668}" type="datetimeFigureOut">
               <a:rPr lang="de-DE" smtClean="0"/>
-              <a:t>11.04.24</a:t>
+              <a:t>15.04.24</a:t>
             </a:fld>
             <a:endParaRPr lang="de-DE"/>
           </a:p>
@@ -668,7 +672,7 @@
           <a:p>
             <a:fld id="{44DFB032-A503-954A-98BF-23F6F2D4C668}" type="datetimeFigureOut">
               <a:rPr lang="de-DE" smtClean="0"/>
-              <a:t>11.04.24</a:t>
+              <a:t>15.04.24</a:t>
             </a:fld>
             <a:endParaRPr lang="de-DE"/>
           </a:p>
@@ -866,7 +870,7 @@
           <a:p>
             <a:fld id="{44DFB032-A503-954A-98BF-23F6F2D4C668}" type="datetimeFigureOut">
               <a:rPr lang="de-DE" smtClean="0"/>
-              <a:t>11.04.24</a:t>
+              <a:t>15.04.24</a:t>
             </a:fld>
             <a:endParaRPr lang="de-DE"/>
           </a:p>
@@ -1141,7 +1145,7 @@
           <a:p>
             <a:fld id="{44DFB032-A503-954A-98BF-23F6F2D4C668}" type="datetimeFigureOut">
               <a:rPr lang="de-DE" smtClean="0"/>
-              <a:t>11.04.24</a:t>
+              <a:t>15.04.24</a:t>
             </a:fld>
             <a:endParaRPr lang="de-DE"/>
           </a:p>
@@ -1406,7 +1410,7 @@
           <a:p>
             <a:fld id="{44DFB032-A503-954A-98BF-23F6F2D4C668}" type="datetimeFigureOut">
               <a:rPr lang="de-DE" smtClean="0"/>
-              <a:t>11.04.24</a:t>
+              <a:t>15.04.24</a:t>
             </a:fld>
             <a:endParaRPr lang="de-DE"/>
           </a:p>
@@ -1818,7 +1822,7 @@
           <a:p>
             <a:fld id="{44DFB032-A503-954A-98BF-23F6F2D4C668}" type="datetimeFigureOut">
               <a:rPr lang="de-DE" smtClean="0"/>
-              <a:t>11.04.24</a:t>
+              <a:t>15.04.24</a:t>
             </a:fld>
             <a:endParaRPr lang="de-DE"/>
           </a:p>
@@ -1959,7 +1963,7 @@
           <a:p>
             <a:fld id="{44DFB032-A503-954A-98BF-23F6F2D4C668}" type="datetimeFigureOut">
               <a:rPr lang="de-DE" smtClean="0"/>
-              <a:t>11.04.24</a:t>
+              <a:t>15.04.24</a:t>
             </a:fld>
             <a:endParaRPr lang="de-DE"/>
           </a:p>
@@ -2072,7 +2076,7 @@
           <a:p>
             <a:fld id="{44DFB032-A503-954A-98BF-23F6F2D4C668}" type="datetimeFigureOut">
               <a:rPr lang="de-DE" smtClean="0"/>
-              <a:t>11.04.24</a:t>
+              <a:t>15.04.24</a:t>
             </a:fld>
             <a:endParaRPr lang="de-DE"/>
           </a:p>
@@ -2383,7 +2387,7 @@
           <a:p>
             <a:fld id="{44DFB032-A503-954A-98BF-23F6F2D4C668}" type="datetimeFigureOut">
               <a:rPr lang="de-DE" smtClean="0"/>
-              <a:t>11.04.24</a:t>
+              <a:t>15.04.24</a:t>
             </a:fld>
             <a:endParaRPr lang="de-DE"/>
           </a:p>
@@ -2671,7 +2675,7 @@
           <a:p>
             <a:fld id="{44DFB032-A503-954A-98BF-23F6F2D4C668}" type="datetimeFigureOut">
               <a:rPr lang="de-DE" smtClean="0"/>
-              <a:t>11.04.24</a:t>
+              <a:t>15.04.24</a:t>
             </a:fld>
             <a:endParaRPr lang="de-DE"/>
           </a:p>
@@ -2912,7 +2916,7 @@
           <a:p>
             <a:fld id="{44DFB032-A503-954A-98BF-23F6F2D4C668}" type="datetimeFigureOut">
               <a:rPr lang="de-DE" smtClean="0"/>
-              <a:t>11.04.24</a:t>
+              <a:t>15.04.24</a:t>
             </a:fld>
             <a:endParaRPr lang="de-DE"/>
           </a:p>
@@ -4735,7 +4739,7 @@
         <p:spPr>
           <a:xfrm>
             <a:off x="5422993" y="1234541"/>
-            <a:ext cx="1148071" cy="369332"/>
+            <a:ext cx="2194832" cy="369332"/>
           </a:xfrm>
           <a:prstGeom prst="rect">
             <a:avLst/>
@@ -4749,6 +4753,10 @@
           <a:lstStyle/>
           <a:p>
             <a:r>
+              <a:rPr lang="de-DE" dirty="0"/>
+              <a:t>maximum </a:t>
+            </a:r>
+            <a:r>
               <a:rPr lang="de-DE" dirty="0" err="1"/>
               <a:t>thickness</a:t>
             </a:r>
@@ -4784,6 +4792,7 @@
           </a:bodyPr>
           <a:lstStyle/>
           <a:p>
+            <a:pPr algn="ctr"/>
             <a:r>
               <a:rPr lang="de-DE" dirty="0" err="1"/>
               <a:t>chord</a:t>
@@ -4791,6 +4800,7 @@
             <a:endParaRPr lang="de-DE" dirty="0"/>
           </a:p>
           <a:p>
+            <a:pPr algn="ctr"/>
             <a:r>
               <a:rPr lang="de-DE" dirty="0" err="1"/>
               <a:t>line</a:t>
@@ -4945,7 +4955,7 @@
         <p:spPr>
           <a:xfrm>
             <a:off x="7716057" y="1813211"/>
-            <a:ext cx="1567096" cy="369332"/>
+            <a:ext cx="1613583" cy="646331"/>
           </a:xfrm>
           <a:prstGeom prst="rect">
             <a:avLst/>
@@ -4970,6 +4980,20 @@
               <a:rPr lang="de-DE" dirty="0" err="1"/>
               <a:t>surface</a:t>
             </a:r>
+            <a:r>
+              <a:rPr lang="de-DE" dirty="0"/>
+              <a:t> </a:t>
+            </a:r>
+          </a:p>
+          <a:p>
+            <a:r>
+              <a:rPr lang="de-DE" dirty="0"/>
+              <a:t>     </a:t>
+            </a:r>
+            <a:r>
+              <a:rPr lang="de-DE" dirty="0" err="1"/>
+              <a:t>camber</a:t>
+            </a:r>
             <a:endParaRPr lang="de-DE" dirty="0"/>
           </a:p>
         </p:txBody>
@@ -4989,7 +5013,7 @@
         <p:spPr>
           <a:xfrm>
             <a:off x="7323451" y="5080886"/>
-            <a:ext cx="1527341" cy="369332"/>
+            <a:ext cx="1527341" cy="646331"/>
           </a:xfrm>
           <a:prstGeom prst="rect">
             <a:avLst/>
@@ -5013,6 +5037,17 @@
             <a:r>
               <a:rPr lang="de-DE" dirty="0" err="1"/>
               <a:t>surface</a:t>
+            </a:r>
+            <a:endParaRPr lang="de-DE" dirty="0"/>
+          </a:p>
+          <a:p>
+            <a:r>
+              <a:rPr lang="de-DE" dirty="0"/>
+              <a:t>   </a:t>
+            </a:r>
+            <a:r>
+              <a:rPr lang="de-DE" dirty="0" err="1"/>
+              <a:t>camber</a:t>
             </a:r>
             <a:endParaRPr lang="de-DE" dirty="0"/>
           </a:p>
@@ -5197,7 +5232,7 @@
         <p:spPr>
           <a:xfrm>
             <a:off x="5920418" y="1792576"/>
-            <a:ext cx="1363130" cy="369332"/>
+            <a:ext cx="1616405" cy="646331"/>
           </a:xfrm>
           <a:prstGeom prst="rect">
             <a:avLst/>
@@ -5212,11 +5247,25 @@
           <a:p>
             <a:r>
               <a:rPr lang="de-DE" dirty="0" err="1"/>
-              <a:t>camber</a:t>
+              <a:t>mean</a:t>
             </a:r>
             <a:r>
               <a:rPr lang="de-DE" dirty="0"/>
               <a:t> </a:t>
+            </a:r>
+            <a:r>
+              <a:rPr lang="de-DE" dirty="0" err="1"/>
+              <a:t>camber</a:t>
+            </a:r>
+            <a:r>
+              <a:rPr lang="de-DE" dirty="0"/>
+              <a:t> </a:t>
+            </a:r>
+          </a:p>
+          <a:p>
+            <a:r>
+              <a:rPr lang="de-DE" dirty="0"/>
+              <a:t>         </a:t>
             </a:r>
             <a:r>
               <a:rPr lang="de-DE" dirty="0" err="1"/>
@@ -6528,6 +6577,1331 @@
     <p:extLst>
       <p:ext uri="{BB962C8B-B14F-4D97-AF65-F5344CB8AC3E}">
         <p14:creationId xmlns:p14="http://schemas.microsoft.com/office/powerpoint/2010/main" val="1680274743"/>
+      </p:ext>
+    </p:extLst>
+  </p:cSld>
+  <p:clrMapOvr>
+    <a:masterClrMapping/>
+  </p:clrMapOvr>
+</p:sld>
+</file>
+
+<file path=ppt/slides/slide5.xml><?xml version="1.0" encoding="utf-8"?>
+<p:sld xmlns:a="http://schemas.openxmlformats.org/drawingml/2006/main" xmlns:r="http://schemas.openxmlformats.org/officeDocument/2006/relationships" xmlns:p="http://schemas.openxmlformats.org/presentationml/2006/main">
+  <p:cSld>
+    <p:spTree>
+      <p:nvGrpSpPr>
+        <p:cNvPr id="1" name=""/>
+        <p:cNvGrpSpPr/>
+        <p:nvPr/>
+      </p:nvGrpSpPr>
+      <p:grpSpPr>
+        <a:xfrm>
+          <a:off x="0" y="0"/>
+          <a:ext cx="0" cy="0"/>
+          <a:chOff x="0" y="0"/>
+          <a:chExt cx="0" cy="0"/>
+        </a:xfrm>
+      </p:grpSpPr>
+      <p:pic>
+        <p:nvPicPr>
+          <p:cNvPr id="3" name="Grafik 2" descr="Ein Bild, das gelb enthält.&#10;&#10;Automatisch generierte Beschreibung">
+            <a:extLst>
+              <a:ext uri="{FF2B5EF4-FFF2-40B4-BE49-F238E27FC236}">
+                <a16:creationId xmlns:a16="http://schemas.microsoft.com/office/drawing/2014/main" id="{B6B07897-6EF7-1590-9CD2-93434BF58D15}"/>
+              </a:ext>
+            </a:extLst>
+          </p:cNvPr>
+          <p:cNvPicPr>
+            <a:picLocks noChangeAspect="1"/>
+          </p:cNvPicPr>
+          <p:nvPr/>
+        </p:nvPicPr>
+        <p:blipFill>
+          <a:blip r:embed="rId2"/>
+          <a:stretch>
+            <a:fillRect/>
+          </a:stretch>
+        </p:blipFill>
+        <p:spPr>
+          <a:xfrm>
+            <a:off x="0" y="2545833"/>
+            <a:ext cx="12104560" cy="1753663"/>
+          </a:xfrm>
+          <a:prstGeom prst="rect">
+            <a:avLst/>
+          </a:prstGeom>
+        </p:spPr>
+      </p:pic>
+      <p:cxnSp>
+        <p:nvCxnSpPr>
+          <p:cNvPr id="5" name="Gerade Verbindung 4">
+            <a:extLst>
+              <a:ext uri="{FF2B5EF4-FFF2-40B4-BE49-F238E27FC236}">
+                <a16:creationId xmlns:a16="http://schemas.microsoft.com/office/drawing/2014/main" id="{85F2C30A-F678-D6EA-B217-3AA0AA1219EE}"/>
+              </a:ext>
+            </a:extLst>
+          </p:cNvPr>
+          <p:cNvCxnSpPr>
+            <a:cxnSpLocks/>
+          </p:cNvCxnSpPr>
+          <p:nvPr/>
+        </p:nvCxnSpPr>
+        <p:spPr>
+          <a:xfrm flipH="1" flipV="1">
+            <a:off x="1053679" y="3578877"/>
+            <a:ext cx="4995895" cy="320948"/>
+          </a:xfrm>
+          <a:prstGeom prst="line">
+            <a:avLst/>
+          </a:prstGeom>
+        </p:spPr>
+        <p:style>
+          <a:lnRef idx="2">
+            <a:schemeClr val="accent1"/>
+          </a:lnRef>
+          <a:fillRef idx="0">
+            <a:schemeClr val="accent1"/>
+          </a:fillRef>
+          <a:effectRef idx="1">
+            <a:schemeClr val="accent1"/>
+          </a:effectRef>
+          <a:fontRef idx="minor">
+            <a:schemeClr val="tx1"/>
+          </a:fontRef>
+        </p:style>
+      </p:cxnSp>
+      <p:cxnSp>
+        <p:nvCxnSpPr>
+          <p:cNvPr id="9" name="Gerade Verbindung 8">
+            <a:extLst>
+              <a:ext uri="{FF2B5EF4-FFF2-40B4-BE49-F238E27FC236}">
+                <a16:creationId xmlns:a16="http://schemas.microsoft.com/office/drawing/2014/main" id="{EDE69D55-5103-5743-003F-F2AAA77F9025}"/>
+              </a:ext>
+            </a:extLst>
+          </p:cNvPr>
+          <p:cNvCxnSpPr>
+            <a:cxnSpLocks/>
+          </p:cNvCxnSpPr>
+          <p:nvPr/>
+        </p:nvCxnSpPr>
+        <p:spPr>
+          <a:xfrm flipH="1" flipV="1">
+            <a:off x="593452" y="3506209"/>
+            <a:ext cx="460227" cy="72668"/>
+          </a:xfrm>
+          <a:prstGeom prst="line">
+            <a:avLst/>
+          </a:prstGeom>
+        </p:spPr>
+        <p:style>
+          <a:lnRef idx="2">
+            <a:schemeClr val="accent1"/>
+          </a:lnRef>
+          <a:fillRef idx="0">
+            <a:schemeClr val="accent1"/>
+          </a:fillRef>
+          <a:effectRef idx="1">
+            <a:schemeClr val="accent1"/>
+          </a:effectRef>
+          <a:fontRef idx="minor">
+            <a:schemeClr val="tx1"/>
+          </a:fontRef>
+        </p:style>
+      </p:cxnSp>
+      <p:cxnSp>
+        <p:nvCxnSpPr>
+          <p:cNvPr id="12" name="Gerade Verbindung 11">
+            <a:extLst>
+              <a:ext uri="{FF2B5EF4-FFF2-40B4-BE49-F238E27FC236}">
+                <a16:creationId xmlns:a16="http://schemas.microsoft.com/office/drawing/2014/main" id="{5EECF671-DDA9-8CF1-3CBB-9179165C4017}"/>
+              </a:ext>
+            </a:extLst>
+          </p:cNvPr>
+          <p:cNvCxnSpPr>
+            <a:cxnSpLocks/>
+          </p:cNvCxnSpPr>
+          <p:nvPr/>
+        </p:nvCxnSpPr>
+        <p:spPr>
+          <a:xfrm flipH="1" flipV="1">
+            <a:off x="163502" y="3360874"/>
+            <a:ext cx="429950" cy="145335"/>
+          </a:xfrm>
+          <a:prstGeom prst="line">
+            <a:avLst/>
+          </a:prstGeom>
+        </p:spPr>
+        <p:style>
+          <a:lnRef idx="2">
+            <a:schemeClr val="accent1"/>
+          </a:lnRef>
+          <a:fillRef idx="0">
+            <a:schemeClr val="accent1"/>
+          </a:fillRef>
+          <a:effectRef idx="1">
+            <a:schemeClr val="accent1"/>
+          </a:effectRef>
+          <a:fontRef idx="minor">
+            <a:schemeClr val="tx1"/>
+          </a:fontRef>
+        </p:style>
+      </p:cxnSp>
+      <p:cxnSp>
+        <p:nvCxnSpPr>
+          <p:cNvPr id="15" name="Gerade Verbindung 14">
+            <a:extLst>
+              <a:ext uri="{FF2B5EF4-FFF2-40B4-BE49-F238E27FC236}">
+                <a16:creationId xmlns:a16="http://schemas.microsoft.com/office/drawing/2014/main" id="{BA0A9AB3-8DCD-4CE1-C893-60B67162C8FD}"/>
+              </a:ext>
+            </a:extLst>
+          </p:cNvPr>
+          <p:cNvCxnSpPr>
+            <a:cxnSpLocks/>
+            <a:stCxn id="3" idx="2"/>
+            <a:endCxn id="3" idx="0"/>
+          </p:cNvCxnSpPr>
+          <p:nvPr/>
+        </p:nvCxnSpPr>
+        <p:spPr>
+          <a:xfrm flipV="1">
+            <a:off x="6052280" y="2545833"/>
+            <a:ext cx="0" cy="1753663"/>
+          </a:xfrm>
+          <a:prstGeom prst="line">
+            <a:avLst/>
+          </a:prstGeom>
+        </p:spPr>
+        <p:style>
+          <a:lnRef idx="2">
+            <a:schemeClr val="accent1"/>
+          </a:lnRef>
+          <a:fillRef idx="0">
+            <a:schemeClr val="accent1"/>
+          </a:fillRef>
+          <a:effectRef idx="1">
+            <a:schemeClr val="accent1"/>
+          </a:effectRef>
+          <a:fontRef idx="minor">
+            <a:schemeClr val="tx1"/>
+          </a:fontRef>
+        </p:style>
+      </p:cxnSp>
+      <p:cxnSp>
+        <p:nvCxnSpPr>
+          <p:cNvPr id="21" name="Gerade Verbindung 20">
+            <a:extLst>
+              <a:ext uri="{FF2B5EF4-FFF2-40B4-BE49-F238E27FC236}">
+                <a16:creationId xmlns:a16="http://schemas.microsoft.com/office/drawing/2014/main" id="{582EE47D-F8CA-12D2-0668-585959DA7822}"/>
+              </a:ext>
+            </a:extLst>
+          </p:cNvPr>
+          <p:cNvCxnSpPr>
+            <a:cxnSpLocks/>
+          </p:cNvCxnSpPr>
+          <p:nvPr/>
+        </p:nvCxnSpPr>
+        <p:spPr>
+          <a:xfrm flipV="1">
+            <a:off x="968845" y="2433585"/>
+            <a:ext cx="261686" cy="1689713"/>
+          </a:xfrm>
+          <a:prstGeom prst="line">
+            <a:avLst/>
+          </a:prstGeom>
+        </p:spPr>
+        <p:style>
+          <a:lnRef idx="2">
+            <a:schemeClr val="accent1"/>
+          </a:lnRef>
+          <a:fillRef idx="0">
+            <a:schemeClr val="accent1"/>
+          </a:fillRef>
+          <a:effectRef idx="1">
+            <a:schemeClr val="accent1"/>
+          </a:effectRef>
+          <a:fontRef idx="minor">
+            <a:schemeClr val="tx1"/>
+          </a:fontRef>
+        </p:style>
+      </p:cxnSp>
+      <p:cxnSp>
+        <p:nvCxnSpPr>
+          <p:cNvPr id="24" name="Gerade Verbindung 23">
+            <a:extLst>
+              <a:ext uri="{FF2B5EF4-FFF2-40B4-BE49-F238E27FC236}">
+                <a16:creationId xmlns:a16="http://schemas.microsoft.com/office/drawing/2014/main" id="{A579F1A3-EEBF-0459-B09E-2F52C37EF6D8}"/>
+              </a:ext>
+            </a:extLst>
+          </p:cNvPr>
+          <p:cNvCxnSpPr>
+            <a:cxnSpLocks/>
+          </p:cNvCxnSpPr>
+          <p:nvPr/>
+        </p:nvCxnSpPr>
+        <p:spPr>
+          <a:xfrm flipV="1">
+            <a:off x="454519" y="2433585"/>
+            <a:ext cx="514326" cy="1546662"/>
+          </a:xfrm>
+          <a:prstGeom prst="line">
+            <a:avLst/>
+          </a:prstGeom>
+        </p:spPr>
+        <p:style>
+          <a:lnRef idx="2">
+            <a:schemeClr val="accent1"/>
+          </a:lnRef>
+          <a:fillRef idx="0">
+            <a:schemeClr val="accent1"/>
+          </a:fillRef>
+          <a:effectRef idx="1">
+            <a:schemeClr val="accent1"/>
+          </a:effectRef>
+          <a:fontRef idx="minor">
+            <a:schemeClr val="tx1"/>
+          </a:fontRef>
+        </p:style>
+      </p:cxnSp>
+      <p:sp>
+        <p:nvSpPr>
+          <p:cNvPr id="30" name="Bogen 29">
+            <a:extLst>
+              <a:ext uri="{FF2B5EF4-FFF2-40B4-BE49-F238E27FC236}">
+                <a16:creationId xmlns:a16="http://schemas.microsoft.com/office/drawing/2014/main" id="{2C165A37-C591-2D00-8D40-097E32FC9F78}"/>
+              </a:ext>
+            </a:extLst>
+          </p:cNvPr>
+          <p:cNvSpPr/>
+          <p:nvPr/>
+        </p:nvSpPr>
+        <p:spPr>
+          <a:xfrm rot="16549207">
+            <a:off x="5552869" y="3459872"/>
+            <a:ext cx="914400" cy="914400"/>
+          </a:xfrm>
+          <a:prstGeom prst="arc">
+            <a:avLst/>
+          </a:prstGeom>
+        </p:spPr>
+        <p:style>
+          <a:lnRef idx="2">
+            <a:schemeClr val="accent1"/>
+          </a:lnRef>
+          <a:fillRef idx="0">
+            <a:schemeClr val="accent1"/>
+          </a:fillRef>
+          <a:effectRef idx="1">
+            <a:schemeClr val="accent1"/>
+          </a:effectRef>
+          <a:fontRef idx="minor">
+            <a:schemeClr val="tx1"/>
+          </a:fontRef>
+        </p:style>
+        <p:txBody>
+          <a:bodyPr rtlCol="0" anchor="ctr"/>
+          <a:lstStyle/>
+          <a:p>
+            <a:pPr algn="ctr"/>
+            <a:endParaRPr lang="de-DE"/>
+          </a:p>
+        </p:txBody>
+      </p:sp>
+      <p:sp>
+        <p:nvSpPr>
+          <p:cNvPr id="32" name="Bogen 31">
+            <a:extLst>
+              <a:ext uri="{FF2B5EF4-FFF2-40B4-BE49-F238E27FC236}">
+                <a16:creationId xmlns:a16="http://schemas.microsoft.com/office/drawing/2014/main" id="{E26174A5-F183-8F8A-DC4C-2CBC3901425A}"/>
+              </a:ext>
+            </a:extLst>
+          </p:cNvPr>
+          <p:cNvSpPr/>
+          <p:nvPr/>
+        </p:nvSpPr>
+        <p:spPr>
+          <a:xfrm rot="507830">
+            <a:off x="803316" y="3303278"/>
+            <a:ext cx="516085" cy="516085"/>
+          </a:xfrm>
+          <a:prstGeom prst="arc">
+            <a:avLst/>
+          </a:prstGeom>
+        </p:spPr>
+        <p:style>
+          <a:lnRef idx="2">
+            <a:schemeClr val="accent1"/>
+          </a:lnRef>
+          <a:fillRef idx="0">
+            <a:schemeClr val="accent1"/>
+          </a:fillRef>
+          <a:effectRef idx="1">
+            <a:schemeClr val="accent1"/>
+          </a:effectRef>
+          <a:fontRef idx="minor">
+            <a:schemeClr val="tx1"/>
+          </a:fontRef>
+        </p:style>
+        <p:txBody>
+          <a:bodyPr rtlCol="0" anchor="ctr"/>
+          <a:lstStyle/>
+          <a:p>
+            <a:pPr algn="ctr"/>
+            <a:endParaRPr lang="de-DE"/>
+          </a:p>
+        </p:txBody>
+      </p:sp>
+      <p:sp>
+        <p:nvSpPr>
+          <p:cNvPr id="35" name="Bogen 34">
+            <a:extLst>
+              <a:ext uri="{FF2B5EF4-FFF2-40B4-BE49-F238E27FC236}">
+                <a16:creationId xmlns:a16="http://schemas.microsoft.com/office/drawing/2014/main" id="{6121C4B4-8685-499C-23A6-449E5E427F2C}"/>
+              </a:ext>
+            </a:extLst>
+          </p:cNvPr>
+          <p:cNvSpPr/>
+          <p:nvPr/>
+        </p:nvSpPr>
+        <p:spPr>
+          <a:xfrm rot="829964">
+            <a:off x="386876" y="3232081"/>
+            <a:ext cx="516085" cy="516085"/>
+          </a:xfrm>
+          <a:prstGeom prst="arc">
+            <a:avLst/>
+          </a:prstGeom>
+        </p:spPr>
+        <p:style>
+          <a:lnRef idx="2">
+            <a:schemeClr val="accent1"/>
+          </a:lnRef>
+          <a:fillRef idx="0">
+            <a:schemeClr val="accent1"/>
+          </a:fillRef>
+          <a:effectRef idx="1">
+            <a:schemeClr val="accent1"/>
+          </a:effectRef>
+          <a:fontRef idx="minor">
+            <a:schemeClr val="tx1"/>
+          </a:fontRef>
+        </p:style>
+        <p:txBody>
+          <a:bodyPr rtlCol="0" anchor="ctr"/>
+          <a:lstStyle/>
+          <a:p>
+            <a:pPr algn="ctr"/>
+            <a:endParaRPr lang="de-DE"/>
+          </a:p>
+        </p:txBody>
+      </p:sp>
+      <p:sp>
+        <p:nvSpPr>
+          <p:cNvPr id="36" name="Textfeld 35">
+            <a:extLst>
+              <a:ext uri="{FF2B5EF4-FFF2-40B4-BE49-F238E27FC236}">
+                <a16:creationId xmlns:a16="http://schemas.microsoft.com/office/drawing/2014/main" id="{149325EE-BF5E-7B13-1D06-0A744D67432B}"/>
+              </a:ext>
+            </a:extLst>
+          </p:cNvPr>
+          <p:cNvSpPr txBox="1"/>
+          <p:nvPr/>
+        </p:nvSpPr>
+        <p:spPr>
+          <a:xfrm>
+            <a:off x="2376080" y="1978367"/>
+            <a:ext cx="1832105" cy="369332"/>
+          </a:xfrm>
+          <a:prstGeom prst="rect">
+            <a:avLst/>
+          </a:prstGeom>
+          <a:noFill/>
+        </p:spPr>
+        <p:txBody>
+          <a:bodyPr wrap="none" rtlCol="0">
+            <a:spAutoFit/>
+          </a:bodyPr>
+          <a:lstStyle/>
+          <a:p>
+            <a:r>
+              <a:rPr lang="de-DE" dirty="0"/>
+              <a:t>angle </a:t>
+            </a:r>
+            <a:r>
+              <a:rPr lang="de-DE" dirty="0" err="1"/>
+              <a:t>of</a:t>
+            </a:r>
+            <a:r>
+              <a:rPr lang="de-DE" dirty="0"/>
+              <a:t> </a:t>
+            </a:r>
+            <a:r>
+              <a:rPr lang="de-DE" dirty="0" err="1"/>
+              <a:t>dihedral</a:t>
+            </a:r>
+            <a:endParaRPr lang="de-DE" dirty="0"/>
+          </a:p>
+        </p:txBody>
+      </p:sp>
+      <p:cxnSp>
+        <p:nvCxnSpPr>
+          <p:cNvPr id="38" name="Gerade Verbindung mit Pfeil 37">
+            <a:extLst>
+              <a:ext uri="{FF2B5EF4-FFF2-40B4-BE49-F238E27FC236}">
+                <a16:creationId xmlns:a16="http://schemas.microsoft.com/office/drawing/2014/main" id="{F27D8308-A682-D1A2-DAD1-2279A5295575}"/>
+              </a:ext>
+            </a:extLst>
+          </p:cNvPr>
+          <p:cNvCxnSpPr>
+            <a:cxnSpLocks/>
+          </p:cNvCxnSpPr>
+          <p:nvPr/>
+        </p:nvCxnSpPr>
+        <p:spPr>
+          <a:xfrm>
+            <a:off x="3650801" y="2322360"/>
+            <a:ext cx="2032756" cy="1238960"/>
+          </a:xfrm>
+          <a:prstGeom prst="straightConnector1">
+            <a:avLst/>
+          </a:prstGeom>
+          <a:ln>
+            <a:solidFill>
+              <a:schemeClr val="tx1"/>
+            </a:solidFill>
+            <a:tailEnd type="triangle"/>
+          </a:ln>
+        </p:spPr>
+        <p:style>
+          <a:lnRef idx="2">
+            <a:schemeClr val="accent1"/>
+          </a:lnRef>
+          <a:fillRef idx="0">
+            <a:schemeClr val="accent1"/>
+          </a:fillRef>
+          <a:effectRef idx="1">
+            <a:schemeClr val="accent1"/>
+          </a:effectRef>
+          <a:fontRef idx="minor">
+            <a:schemeClr val="tx1"/>
+          </a:fontRef>
+        </p:style>
+      </p:cxnSp>
+      <p:cxnSp>
+        <p:nvCxnSpPr>
+          <p:cNvPr id="41" name="Gerade Verbindung mit Pfeil 40">
+            <a:extLst>
+              <a:ext uri="{FF2B5EF4-FFF2-40B4-BE49-F238E27FC236}">
+                <a16:creationId xmlns:a16="http://schemas.microsoft.com/office/drawing/2014/main" id="{BE941967-1373-015F-9B5E-C264A155E8E0}"/>
+              </a:ext>
+            </a:extLst>
+          </p:cNvPr>
+          <p:cNvCxnSpPr>
+            <a:cxnSpLocks/>
+          </p:cNvCxnSpPr>
+          <p:nvPr/>
+        </p:nvCxnSpPr>
+        <p:spPr>
+          <a:xfrm flipH="1">
+            <a:off x="1289837" y="2338713"/>
+            <a:ext cx="1558740" cy="1029967"/>
+          </a:xfrm>
+          <a:prstGeom prst="straightConnector1">
+            <a:avLst/>
+          </a:prstGeom>
+          <a:ln>
+            <a:solidFill>
+              <a:schemeClr val="tx1"/>
+            </a:solidFill>
+            <a:tailEnd type="triangle"/>
+          </a:ln>
+        </p:spPr>
+        <p:style>
+          <a:lnRef idx="2">
+            <a:schemeClr val="accent1"/>
+          </a:lnRef>
+          <a:fillRef idx="0">
+            <a:schemeClr val="accent1"/>
+          </a:fillRef>
+          <a:effectRef idx="1">
+            <a:schemeClr val="accent1"/>
+          </a:effectRef>
+          <a:fontRef idx="minor">
+            <a:schemeClr val="tx1"/>
+          </a:fontRef>
+        </p:style>
+      </p:cxnSp>
+      <p:cxnSp>
+        <p:nvCxnSpPr>
+          <p:cNvPr id="44" name="Gerade Verbindung mit Pfeil 43">
+            <a:extLst>
+              <a:ext uri="{FF2B5EF4-FFF2-40B4-BE49-F238E27FC236}">
+                <a16:creationId xmlns:a16="http://schemas.microsoft.com/office/drawing/2014/main" id="{A1C364C8-B967-8972-834F-7F1F7283D30F}"/>
+              </a:ext>
+            </a:extLst>
+          </p:cNvPr>
+          <p:cNvCxnSpPr>
+            <a:cxnSpLocks/>
+          </p:cNvCxnSpPr>
+          <p:nvPr/>
+        </p:nvCxnSpPr>
+        <p:spPr>
+          <a:xfrm flipH="1">
+            <a:off x="846352" y="2312412"/>
+            <a:ext cx="1717388" cy="983286"/>
+          </a:xfrm>
+          <a:prstGeom prst="straightConnector1">
+            <a:avLst/>
+          </a:prstGeom>
+          <a:ln>
+            <a:solidFill>
+              <a:schemeClr val="tx1"/>
+            </a:solidFill>
+            <a:tailEnd type="triangle"/>
+          </a:ln>
+        </p:spPr>
+        <p:style>
+          <a:lnRef idx="2">
+            <a:schemeClr val="accent1"/>
+          </a:lnRef>
+          <a:fillRef idx="0">
+            <a:schemeClr val="accent1"/>
+          </a:fillRef>
+          <a:effectRef idx="1">
+            <a:schemeClr val="accent1"/>
+          </a:effectRef>
+          <a:fontRef idx="minor">
+            <a:schemeClr val="tx1"/>
+          </a:fontRef>
+        </p:style>
+      </p:cxnSp>
+      <p:cxnSp>
+        <p:nvCxnSpPr>
+          <p:cNvPr id="48" name="Gerade Verbindung mit Pfeil 47">
+            <a:extLst>
+              <a:ext uri="{FF2B5EF4-FFF2-40B4-BE49-F238E27FC236}">
+                <a16:creationId xmlns:a16="http://schemas.microsoft.com/office/drawing/2014/main" id="{41458ACD-0E6A-04C9-3E1E-9E4EE7DB5D7C}"/>
+              </a:ext>
+            </a:extLst>
+          </p:cNvPr>
+          <p:cNvCxnSpPr>
+            <a:cxnSpLocks/>
+          </p:cNvCxnSpPr>
+          <p:nvPr/>
+        </p:nvCxnSpPr>
+        <p:spPr>
+          <a:xfrm>
+            <a:off x="3482051" y="2322360"/>
+            <a:ext cx="284837" cy="1249983"/>
+          </a:xfrm>
+          <a:prstGeom prst="straightConnector1">
+            <a:avLst/>
+          </a:prstGeom>
+          <a:ln>
+            <a:solidFill>
+              <a:schemeClr val="tx1"/>
+            </a:solidFill>
+            <a:tailEnd type="triangle"/>
+          </a:ln>
+        </p:spPr>
+        <p:style>
+          <a:lnRef idx="2">
+            <a:schemeClr val="accent1"/>
+          </a:lnRef>
+          <a:fillRef idx="0">
+            <a:schemeClr val="accent1"/>
+          </a:fillRef>
+          <a:effectRef idx="1">
+            <a:schemeClr val="accent1"/>
+          </a:effectRef>
+          <a:fontRef idx="minor">
+            <a:schemeClr val="tx1"/>
+          </a:fontRef>
+        </p:style>
+      </p:cxnSp>
+      <p:sp>
+        <p:nvSpPr>
+          <p:cNvPr id="54" name="Textfeld 53">
+            <a:extLst>
+              <a:ext uri="{FF2B5EF4-FFF2-40B4-BE49-F238E27FC236}">
+                <a16:creationId xmlns:a16="http://schemas.microsoft.com/office/drawing/2014/main" id="{9F2BF37A-8D38-B530-9D4E-868E45FA16A6}"/>
+              </a:ext>
+            </a:extLst>
+          </p:cNvPr>
+          <p:cNvSpPr txBox="1"/>
+          <p:nvPr/>
+        </p:nvSpPr>
+        <p:spPr>
+          <a:xfrm rot="19760275">
+            <a:off x="1617656" y="2414902"/>
+            <a:ext cx="444352" cy="369332"/>
+          </a:xfrm>
+          <a:prstGeom prst="rect">
+            <a:avLst/>
+          </a:prstGeom>
+          <a:noFill/>
+        </p:spPr>
+        <p:txBody>
+          <a:bodyPr wrap="none" rtlCol="0">
+            <a:spAutoFit/>
+          </a:bodyPr>
+          <a:lstStyle/>
+          <a:p>
+            <a:r>
+              <a:rPr lang="de-DE" dirty="0" err="1"/>
+              <a:t>tip</a:t>
+            </a:r>
+            <a:endParaRPr lang="de-DE" dirty="0"/>
+          </a:p>
+        </p:txBody>
+      </p:sp>
+      <p:sp>
+        <p:nvSpPr>
+          <p:cNvPr id="55" name="Textfeld 54">
+            <a:extLst>
+              <a:ext uri="{FF2B5EF4-FFF2-40B4-BE49-F238E27FC236}">
+                <a16:creationId xmlns:a16="http://schemas.microsoft.com/office/drawing/2014/main" id="{553B1209-0A4D-D8B5-4A48-F1E874BAF6E7}"/>
+              </a:ext>
+            </a:extLst>
+          </p:cNvPr>
+          <p:cNvSpPr txBox="1"/>
+          <p:nvPr/>
+        </p:nvSpPr>
+        <p:spPr>
+          <a:xfrm rot="1863380">
+            <a:off x="4520327" y="2734274"/>
+            <a:ext cx="587084" cy="369332"/>
+          </a:xfrm>
+          <a:prstGeom prst="rect">
+            <a:avLst/>
+          </a:prstGeom>
+          <a:noFill/>
+        </p:spPr>
+        <p:txBody>
+          <a:bodyPr wrap="none" rtlCol="0">
+            <a:spAutoFit/>
+          </a:bodyPr>
+          <a:lstStyle/>
+          <a:p>
+            <a:r>
+              <a:rPr lang="de-DE" dirty="0"/>
+              <a:t>root</a:t>
+            </a:r>
+          </a:p>
+        </p:txBody>
+      </p:sp>
+      <p:sp>
+        <p:nvSpPr>
+          <p:cNvPr id="56" name="Textfeld 55">
+            <a:extLst>
+              <a:ext uri="{FF2B5EF4-FFF2-40B4-BE49-F238E27FC236}">
+                <a16:creationId xmlns:a16="http://schemas.microsoft.com/office/drawing/2014/main" id="{438E64DA-E691-F67E-288B-7D5C495DA3E4}"/>
+              </a:ext>
+            </a:extLst>
+          </p:cNvPr>
+          <p:cNvSpPr txBox="1"/>
+          <p:nvPr/>
+        </p:nvSpPr>
+        <p:spPr>
+          <a:xfrm rot="19496362">
+            <a:off x="1502999" y="2765451"/>
+            <a:ext cx="444352" cy="369332"/>
+          </a:xfrm>
+          <a:prstGeom prst="rect">
+            <a:avLst/>
+          </a:prstGeom>
+          <a:noFill/>
+        </p:spPr>
+        <p:txBody>
+          <a:bodyPr wrap="none" rtlCol="0">
+            <a:spAutoFit/>
+          </a:bodyPr>
+          <a:lstStyle/>
+          <a:p>
+            <a:r>
+              <a:rPr lang="de-DE" dirty="0" err="1"/>
+              <a:t>tip</a:t>
+            </a:r>
+            <a:endParaRPr lang="de-DE" dirty="0"/>
+          </a:p>
+        </p:txBody>
+      </p:sp>
+    </p:spTree>
+    <p:extLst>
+      <p:ext uri="{BB962C8B-B14F-4D97-AF65-F5344CB8AC3E}">
+        <p14:creationId xmlns:p14="http://schemas.microsoft.com/office/powerpoint/2010/main" val="836946149"/>
+      </p:ext>
+    </p:extLst>
+  </p:cSld>
+  <p:clrMapOvr>
+    <a:masterClrMapping/>
+  </p:clrMapOvr>
+</p:sld>
+</file>
+
+<file path=ppt/slides/slide6.xml><?xml version="1.0" encoding="utf-8"?>
+<p:sld xmlns:a="http://schemas.openxmlformats.org/drawingml/2006/main" xmlns:r="http://schemas.openxmlformats.org/officeDocument/2006/relationships" xmlns:p="http://schemas.openxmlformats.org/presentationml/2006/main">
+  <p:cSld>
+    <p:spTree>
+      <p:nvGrpSpPr>
+        <p:cNvPr id="1" name=""/>
+        <p:cNvGrpSpPr/>
+        <p:nvPr/>
+      </p:nvGrpSpPr>
+      <p:grpSpPr>
+        <a:xfrm>
+          <a:off x="0" y="0"/>
+          <a:ext cx="0" cy="0"/>
+          <a:chOff x="0" y="0"/>
+          <a:chExt cx="0" cy="0"/>
+        </a:xfrm>
+      </p:grpSpPr>
+      <p:pic>
+        <p:nvPicPr>
+          <p:cNvPr id="3" name="Grafik 2" descr="Ein Bild, das gelb, Design enthält.&#10;&#10;Automatisch generierte Beschreibung">
+            <a:extLst>
+              <a:ext uri="{FF2B5EF4-FFF2-40B4-BE49-F238E27FC236}">
+                <a16:creationId xmlns:a16="http://schemas.microsoft.com/office/drawing/2014/main" id="{837FAEB3-8A0C-9FCF-CCAF-0BB8DC417F2D}"/>
+              </a:ext>
+            </a:extLst>
+          </p:cNvPr>
+          <p:cNvPicPr>
+            <a:picLocks noChangeAspect="1"/>
+          </p:cNvPicPr>
+          <p:nvPr/>
+        </p:nvPicPr>
+        <p:blipFill>
+          <a:blip r:embed="rId2"/>
+          <a:stretch>
+            <a:fillRect/>
+          </a:stretch>
+        </p:blipFill>
+        <p:spPr>
+          <a:xfrm rot="5400000">
+            <a:off x="3320149" y="221350"/>
+            <a:ext cx="4233214" cy="8190348"/>
+          </a:xfrm>
+          <a:prstGeom prst="rect">
+            <a:avLst/>
+          </a:prstGeom>
+        </p:spPr>
+      </p:pic>
+      <p:cxnSp>
+        <p:nvCxnSpPr>
+          <p:cNvPr id="5" name="Gerade Verbindung 4">
+            <a:extLst>
+              <a:ext uri="{FF2B5EF4-FFF2-40B4-BE49-F238E27FC236}">
+                <a16:creationId xmlns:a16="http://schemas.microsoft.com/office/drawing/2014/main" id="{CF66CB7A-26D8-0CE5-D161-7E7C635E3804}"/>
+              </a:ext>
+            </a:extLst>
+          </p:cNvPr>
+          <p:cNvCxnSpPr>
+            <a:cxnSpLocks/>
+          </p:cNvCxnSpPr>
+          <p:nvPr/>
+        </p:nvCxnSpPr>
+        <p:spPr>
+          <a:xfrm>
+            <a:off x="1341582" y="2687782"/>
+            <a:ext cx="5807363" cy="0"/>
+          </a:xfrm>
+          <a:prstGeom prst="line">
+            <a:avLst/>
+          </a:prstGeom>
+        </p:spPr>
+        <p:style>
+          <a:lnRef idx="2">
+            <a:schemeClr val="accent1"/>
+          </a:lnRef>
+          <a:fillRef idx="0">
+            <a:schemeClr val="accent1"/>
+          </a:fillRef>
+          <a:effectRef idx="1">
+            <a:schemeClr val="accent1"/>
+          </a:effectRef>
+          <a:fontRef idx="minor">
+            <a:schemeClr val="tx1"/>
+          </a:fontRef>
+        </p:style>
+      </p:cxnSp>
+      <p:cxnSp>
+        <p:nvCxnSpPr>
+          <p:cNvPr id="7" name="Gerade Verbindung 6">
+            <a:extLst>
+              <a:ext uri="{FF2B5EF4-FFF2-40B4-BE49-F238E27FC236}">
+                <a16:creationId xmlns:a16="http://schemas.microsoft.com/office/drawing/2014/main" id="{F1962BE8-288F-685B-1EBD-1CAF17A7A609}"/>
+              </a:ext>
+            </a:extLst>
+          </p:cNvPr>
+          <p:cNvCxnSpPr>
+            <a:cxnSpLocks/>
+          </p:cNvCxnSpPr>
+          <p:nvPr/>
+        </p:nvCxnSpPr>
+        <p:spPr>
+          <a:xfrm>
+            <a:off x="5158512" y="2881746"/>
+            <a:ext cx="2877124" cy="0"/>
+          </a:xfrm>
+          <a:prstGeom prst="line">
+            <a:avLst/>
+          </a:prstGeom>
+        </p:spPr>
+        <p:style>
+          <a:lnRef idx="2">
+            <a:schemeClr val="accent1"/>
+          </a:lnRef>
+          <a:fillRef idx="0">
+            <a:schemeClr val="accent1"/>
+          </a:fillRef>
+          <a:effectRef idx="1">
+            <a:schemeClr val="accent1"/>
+          </a:effectRef>
+          <a:fontRef idx="minor">
+            <a:schemeClr val="tx1"/>
+          </a:fontRef>
+        </p:style>
+      </p:cxnSp>
+      <p:cxnSp>
+        <p:nvCxnSpPr>
+          <p:cNvPr id="8" name="Gerade Verbindung 7">
+            <a:extLst>
+              <a:ext uri="{FF2B5EF4-FFF2-40B4-BE49-F238E27FC236}">
+                <a16:creationId xmlns:a16="http://schemas.microsoft.com/office/drawing/2014/main" id="{A3FA8304-59AD-F6A1-58AE-B954B29C6E34}"/>
+              </a:ext>
+            </a:extLst>
+          </p:cNvPr>
+          <p:cNvCxnSpPr>
+            <a:cxnSpLocks/>
+          </p:cNvCxnSpPr>
+          <p:nvPr/>
+        </p:nvCxnSpPr>
+        <p:spPr>
+          <a:xfrm>
+            <a:off x="7015021" y="3068783"/>
+            <a:ext cx="1969652" cy="0"/>
+          </a:xfrm>
+          <a:prstGeom prst="line">
+            <a:avLst/>
+          </a:prstGeom>
+        </p:spPr>
+        <p:style>
+          <a:lnRef idx="2">
+            <a:schemeClr val="accent1"/>
+          </a:lnRef>
+          <a:fillRef idx="0">
+            <a:schemeClr val="accent1"/>
+          </a:fillRef>
+          <a:effectRef idx="1">
+            <a:schemeClr val="accent1"/>
+          </a:effectRef>
+          <a:fontRef idx="minor">
+            <a:schemeClr val="tx1"/>
+          </a:fontRef>
+        </p:style>
+      </p:cxnSp>
+      <p:cxnSp>
+        <p:nvCxnSpPr>
+          <p:cNvPr id="9" name="Gerade Verbindung 8">
+            <a:extLst>
+              <a:ext uri="{FF2B5EF4-FFF2-40B4-BE49-F238E27FC236}">
+                <a16:creationId xmlns:a16="http://schemas.microsoft.com/office/drawing/2014/main" id="{3689DC3B-93F5-32FD-4C0B-CD74430CBAE6}"/>
+              </a:ext>
+            </a:extLst>
+          </p:cNvPr>
+          <p:cNvCxnSpPr>
+            <a:cxnSpLocks/>
+          </p:cNvCxnSpPr>
+          <p:nvPr/>
+        </p:nvCxnSpPr>
+        <p:spPr>
+          <a:xfrm>
+            <a:off x="7887858" y="3269674"/>
+            <a:ext cx="1644072" cy="0"/>
+          </a:xfrm>
+          <a:prstGeom prst="line">
+            <a:avLst/>
+          </a:prstGeom>
+        </p:spPr>
+        <p:style>
+          <a:lnRef idx="2">
+            <a:schemeClr val="accent1"/>
+          </a:lnRef>
+          <a:fillRef idx="0">
+            <a:schemeClr val="accent1"/>
+          </a:fillRef>
+          <a:effectRef idx="1">
+            <a:schemeClr val="accent1"/>
+          </a:effectRef>
+          <a:fontRef idx="minor">
+            <a:schemeClr val="tx1"/>
+          </a:fontRef>
+        </p:style>
+      </p:cxnSp>
+      <p:sp>
+        <p:nvSpPr>
+          <p:cNvPr id="26" name="Geschweifte Klammer links 25">
+            <a:extLst>
+              <a:ext uri="{FF2B5EF4-FFF2-40B4-BE49-F238E27FC236}">
+                <a16:creationId xmlns:a16="http://schemas.microsoft.com/office/drawing/2014/main" id="{096443C2-5386-76B0-B7EE-E04C01852721}"/>
+              </a:ext>
+            </a:extLst>
+          </p:cNvPr>
+          <p:cNvSpPr/>
+          <p:nvPr/>
+        </p:nvSpPr>
+        <p:spPr>
+          <a:xfrm flipH="1">
+            <a:off x="8091054" y="2687782"/>
+            <a:ext cx="173181" cy="193964"/>
+          </a:xfrm>
+          <a:prstGeom prst="leftBrace">
+            <a:avLst/>
+          </a:prstGeom>
+        </p:spPr>
+        <p:style>
+          <a:lnRef idx="2">
+            <a:schemeClr val="accent1"/>
+          </a:lnRef>
+          <a:fillRef idx="0">
+            <a:schemeClr val="accent1"/>
+          </a:fillRef>
+          <a:effectRef idx="1">
+            <a:schemeClr val="accent1"/>
+          </a:effectRef>
+          <a:fontRef idx="minor">
+            <a:schemeClr val="tx1"/>
+          </a:fontRef>
+        </p:style>
+        <p:txBody>
+          <a:bodyPr rtlCol="0" anchor="ctr"/>
+          <a:lstStyle/>
+          <a:p>
+            <a:pPr algn="ctr"/>
+            <a:endParaRPr lang="de-DE"/>
+          </a:p>
+        </p:txBody>
+      </p:sp>
+      <p:sp>
+        <p:nvSpPr>
+          <p:cNvPr id="27" name="Geschweifte Klammer links 26">
+            <a:extLst>
+              <a:ext uri="{FF2B5EF4-FFF2-40B4-BE49-F238E27FC236}">
+                <a16:creationId xmlns:a16="http://schemas.microsoft.com/office/drawing/2014/main" id="{82045A06-BF8D-E46A-2F4C-746EB525311F}"/>
+              </a:ext>
+            </a:extLst>
+          </p:cNvPr>
+          <p:cNvSpPr/>
+          <p:nvPr/>
+        </p:nvSpPr>
+        <p:spPr>
+          <a:xfrm flipH="1">
+            <a:off x="8998529" y="2881745"/>
+            <a:ext cx="173182" cy="187037"/>
+          </a:xfrm>
+          <a:prstGeom prst="leftBrace">
+            <a:avLst/>
+          </a:prstGeom>
+        </p:spPr>
+        <p:style>
+          <a:lnRef idx="2">
+            <a:schemeClr val="accent1"/>
+          </a:lnRef>
+          <a:fillRef idx="0">
+            <a:schemeClr val="accent1"/>
+          </a:fillRef>
+          <a:effectRef idx="1">
+            <a:schemeClr val="accent1"/>
+          </a:effectRef>
+          <a:fontRef idx="minor">
+            <a:schemeClr val="tx1"/>
+          </a:fontRef>
+        </p:style>
+        <p:txBody>
+          <a:bodyPr rtlCol="0" anchor="ctr"/>
+          <a:lstStyle/>
+          <a:p>
+            <a:pPr algn="ctr"/>
+            <a:endParaRPr lang="de-DE"/>
+          </a:p>
+        </p:txBody>
+      </p:sp>
+      <p:sp>
+        <p:nvSpPr>
+          <p:cNvPr id="28" name="Geschweifte Klammer links 27">
+            <a:extLst>
+              <a:ext uri="{FF2B5EF4-FFF2-40B4-BE49-F238E27FC236}">
+                <a16:creationId xmlns:a16="http://schemas.microsoft.com/office/drawing/2014/main" id="{B269B9F3-0341-A5FB-2C5C-68C6213F4CB4}"/>
+              </a:ext>
+            </a:extLst>
+          </p:cNvPr>
+          <p:cNvSpPr/>
+          <p:nvPr/>
+        </p:nvSpPr>
+        <p:spPr>
+          <a:xfrm flipH="1">
+            <a:off x="9583885" y="3082637"/>
+            <a:ext cx="173182" cy="187037"/>
+          </a:xfrm>
+          <a:prstGeom prst="leftBrace">
+            <a:avLst/>
+          </a:prstGeom>
+        </p:spPr>
+        <p:style>
+          <a:lnRef idx="2">
+            <a:schemeClr val="accent1"/>
+          </a:lnRef>
+          <a:fillRef idx="0">
+            <a:schemeClr val="accent1"/>
+          </a:fillRef>
+          <a:effectRef idx="1">
+            <a:schemeClr val="accent1"/>
+          </a:effectRef>
+          <a:fontRef idx="minor">
+            <a:schemeClr val="tx1"/>
+          </a:fontRef>
+        </p:style>
+        <p:txBody>
+          <a:bodyPr rtlCol="0" anchor="ctr"/>
+          <a:lstStyle/>
+          <a:p>
+            <a:pPr algn="ctr"/>
+            <a:endParaRPr lang="de-DE"/>
+          </a:p>
+        </p:txBody>
+      </p:sp>
+      <p:sp>
+        <p:nvSpPr>
+          <p:cNvPr id="33" name="Textfeld 32">
+            <a:extLst>
+              <a:ext uri="{FF2B5EF4-FFF2-40B4-BE49-F238E27FC236}">
+                <a16:creationId xmlns:a16="http://schemas.microsoft.com/office/drawing/2014/main" id="{6D7ACBD0-BCE9-FA66-F252-CD7777EE2221}"/>
+              </a:ext>
+            </a:extLst>
+          </p:cNvPr>
+          <p:cNvSpPr txBox="1"/>
+          <p:nvPr/>
+        </p:nvSpPr>
+        <p:spPr>
+          <a:xfrm>
+            <a:off x="8264235" y="2596633"/>
+            <a:ext cx="832023" cy="369332"/>
+          </a:xfrm>
+          <a:prstGeom prst="rect">
+            <a:avLst/>
+          </a:prstGeom>
+          <a:noFill/>
+        </p:spPr>
+        <p:txBody>
+          <a:bodyPr wrap="none" rtlCol="0">
+            <a:spAutoFit/>
+          </a:bodyPr>
+          <a:lstStyle/>
+          <a:p>
+            <a:r>
+              <a:rPr lang="de-DE" dirty="0" err="1"/>
+              <a:t>sweep</a:t>
+            </a:r>
+            <a:endParaRPr lang="de-DE" dirty="0"/>
+          </a:p>
+        </p:txBody>
+      </p:sp>
+      <p:sp>
+        <p:nvSpPr>
+          <p:cNvPr id="34" name="Textfeld 33">
+            <a:extLst>
+              <a:ext uri="{FF2B5EF4-FFF2-40B4-BE49-F238E27FC236}">
+                <a16:creationId xmlns:a16="http://schemas.microsoft.com/office/drawing/2014/main" id="{03647B0B-F5AC-FBB7-0502-F0FFE9791700}"/>
+              </a:ext>
+            </a:extLst>
+          </p:cNvPr>
+          <p:cNvSpPr txBox="1"/>
+          <p:nvPr/>
+        </p:nvSpPr>
+        <p:spPr>
+          <a:xfrm>
+            <a:off x="9157854" y="2781299"/>
+            <a:ext cx="832023" cy="369332"/>
+          </a:xfrm>
+          <a:prstGeom prst="rect">
+            <a:avLst/>
+          </a:prstGeom>
+          <a:noFill/>
+        </p:spPr>
+        <p:txBody>
+          <a:bodyPr wrap="none" rtlCol="0">
+            <a:spAutoFit/>
+          </a:bodyPr>
+          <a:lstStyle/>
+          <a:p>
+            <a:r>
+              <a:rPr lang="de-DE" dirty="0" err="1"/>
+              <a:t>sweep</a:t>
+            </a:r>
+            <a:endParaRPr lang="de-DE" dirty="0"/>
+          </a:p>
+        </p:txBody>
+      </p:sp>
+      <p:sp>
+        <p:nvSpPr>
+          <p:cNvPr id="35" name="Textfeld 34">
+            <a:extLst>
+              <a:ext uri="{FF2B5EF4-FFF2-40B4-BE49-F238E27FC236}">
+                <a16:creationId xmlns:a16="http://schemas.microsoft.com/office/drawing/2014/main" id="{BCAAC88A-94CD-BBF3-ADDA-050A4BA2607A}"/>
+              </a:ext>
+            </a:extLst>
+          </p:cNvPr>
+          <p:cNvSpPr txBox="1"/>
+          <p:nvPr/>
+        </p:nvSpPr>
+        <p:spPr>
+          <a:xfrm>
+            <a:off x="9764744" y="2991489"/>
+            <a:ext cx="832023" cy="369332"/>
+          </a:xfrm>
+          <a:prstGeom prst="rect">
+            <a:avLst/>
+          </a:prstGeom>
+          <a:noFill/>
+        </p:spPr>
+        <p:txBody>
+          <a:bodyPr wrap="none" rtlCol="0">
+            <a:spAutoFit/>
+          </a:bodyPr>
+          <a:lstStyle/>
+          <a:p>
+            <a:r>
+              <a:rPr lang="de-DE" dirty="0" err="1"/>
+              <a:t>sweep</a:t>
+            </a:r>
+            <a:endParaRPr lang="de-DE" dirty="0"/>
+          </a:p>
+        </p:txBody>
+      </p:sp>
+    </p:spTree>
+    <p:extLst>
+      <p:ext uri="{BB962C8B-B14F-4D97-AF65-F5344CB8AC3E}">
+        <p14:creationId xmlns:p14="http://schemas.microsoft.com/office/powerpoint/2010/main" val="1347152792"/>
+      </p:ext>
+    </p:extLst>
+  </p:cSld>
+  <p:clrMapOvr>
+    <a:masterClrMapping/>
+  </p:clrMapOvr>
+</p:sld>
+</file>
+
+<file path=ppt/slides/slide7.xml><?xml version="1.0" encoding="utf-8"?>
+<p:sld xmlns:a="http://schemas.openxmlformats.org/drawingml/2006/main" xmlns:r="http://schemas.openxmlformats.org/officeDocument/2006/relationships" xmlns:p="http://schemas.openxmlformats.org/presentationml/2006/main">
+  <p:cSld>
+    <p:spTree>
+      <p:nvGrpSpPr>
+        <p:cNvPr id="1" name=""/>
+        <p:cNvGrpSpPr/>
+        <p:nvPr/>
+      </p:nvGrpSpPr>
+      <p:grpSpPr>
+        <a:xfrm>
+          <a:off x="0" y="0"/>
+          <a:ext cx="0" cy="0"/>
+          <a:chOff x="0" y="0"/>
+          <a:chExt cx="0" cy="0"/>
+        </a:xfrm>
+      </p:grpSpPr>
+      <p:pic>
+        <p:nvPicPr>
+          <p:cNvPr id="3" name="Grafik 2" descr="Ein Bild, das Zeichnung, Entwurf, Kunst, Darstellung enthält.&#10;&#10;Automatisch generierte Beschreibung">
+            <a:extLst>
+              <a:ext uri="{FF2B5EF4-FFF2-40B4-BE49-F238E27FC236}">
+                <a16:creationId xmlns:a16="http://schemas.microsoft.com/office/drawing/2014/main" id="{85A5BE6B-FB0A-6420-32EB-1FC3E6AC68F2}"/>
+              </a:ext>
+            </a:extLst>
+          </p:cNvPr>
+          <p:cNvPicPr>
+            <a:picLocks noChangeAspect="1"/>
+          </p:cNvPicPr>
+          <p:nvPr/>
+        </p:nvPicPr>
+        <p:blipFill>
+          <a:blip r:embed="rId2"/>
+          <a:stretch>
+            <a:fillRect/>
+          </a:stretch>
+        </p:blipFill>
+        <p:spPr>
+          <a:xfrm>
+            <a:off x="321922" y="10578"/>
+            <a:ext cx="11336677" cy="6847422"/>
+          </a:xfrm>
+          <a:prstGeom prst="rect">
+            <a:avLst/>
+          </a:prstGeom>
+        </p:spPr>
+      </p:pic>
+    </p:spTree>
+    <p:extLst>
+      <p:ext uri="{BB962C8B-B14F-4D97-AF65-F5344CB8AC3E}">
+        <p14:creationId xmlns:p14="http://schemas.microsoft.com/office/powerpoint/2010/main" val="3901050718"/>
+      </p:ext>
+    </p:extLst>
+  </p:cSld>
+  <p:clrMapOvr>
+    <a:masterClrMapping/>
+  </p:clrMapOvr>
+</p:sld>
+</file>
+
+<file path=ppt/slides/slide8.xml><?xml version="1.0" encoding="utf-8"?>
+<p:sld xmlns:a="http://schemas.openxmlformats.org/drawingml/2006/main" xmlns:r="http://schemas.openxmlformats.org/officeDocument/2006/relationships" xmlns:p="http://schemas.openxmlformats.org/presentationml/2006/main">
+  <p:cSld>
+    <p:spTree>
+      <p:nvGrpSpPr>
+        <p:cNvPr id="1" name=""/>
+        <p:cNvGrpSpPr/>
+        <p:nvPr/>
+      </p:nvGrpSpPr>
+      <p:grpSpPr>
+        <a:xfrm>
+          <a:off x="0" y="0"/>
+          <a:ext cx="0" cy="0"/>
+          <a:chOff x="0" y="0"/>
+          <a:chExt cx="0" cy="0"/>
+        </a:xfrm>
+      </p:grpSpPr>
+      <p:pic>
+        <p:nvPicPr>
+          <p:cNvPr id="3" name="Grafik 2" descr="Ein Bild, das Entwurf, Zeichnung, Diagramm, Design enthält.&#10;&#10;Automatisch generierte Beschreibung">
+            <a:extLst>
+              <a:ext uri="{FF2B5EF4-FFF2-40B4-BE49-F238E27FC236}">
+                <a16:creationId xmlns:a16="http://schemas.microsoft.com/office/drawing/2014/main" id="{05D77828-6DBE-6A9E-A2FD-67B148921713}"/>
+              </a:ext>
+            </a:extLst>
+          </p:cNvPr>
+          <p:cNvPicPr>
+            <a:picLocks noChangeAspect="1"/>
+          </p:cNvPicPr>
+          <p:nvPr/>
+        </p:nvPicPr>
+        <p:blipFill>
+          <a:blip r:embed="rId2"/>
+          <a:stretch>
+            <a:fillRect/>
+          </a:stretch>
+        </p:blipFill>
+        <p:spPr>
+          <a:xfrm>
+            <a:off x="-443347" y="-117764"/>
+            <a:ext cx="13298958" cy="6975764"/>
+          </a:xfrm>
+          <a:prstGeom prst="rect">
+            <a:avLst/>
+          </a:prstGeom>
+        </p:spPr>
+      </p:pic>
+    </p:spTree>
+    <p:extLst>
+      <p:ext uri="{BB962C8B-B14F-4D97-AF65-F5344CB8AC3E}">
+        <p14:creationId xmlns:p14="http://schemas.microsoft.com/office/powerpoint/2010/main" val="878177270"/>
       </p:ext>
     </p:extLst>
   </p:cSld>

</xml_diff>